<commit_message>
feat(presentation): add dedicated System Architecture slide (7-slide master deck)
</commit_message>
<xml_diff>
--- a/SatQuery_AI_SIH2026_Idea_Submission_v2.pptx
+++ b/SatQuery_AI_SIH2026_Idea_Submission_v2.pptx
@@ -11,6 +11,7 @@
     <p:sldId id="259" r:id="rId10"/>
     <p:sldId id="260" r:id="rId11"/>
     <p:sldId id="261" r:id="rId12"/>
+    <p:sldId id="262" r:id="rId13"/>
   </p:sldIdLst>
   <p:sldSz cx="12191695" cy="6858000" type="screen4x3"/>
   <p:notesSz cx="6858000" cy="9144000"/>
@@ -3335,6 +3336,48 @@
 </p:sld>
 </file>
 
+<file path=ppt/slides/slide7.xml><?xml version="1.0" encoding="utf-8"?>
+<p:sld xmlns:a="http://schemas.openxmlformats.org/drawingml/2006/main" xmlns:p="http://schemas.openxmlformats.org/presentationml/2006/main" xmlns:r="http://schemas.openxmlformats.org/officeDocument/2006/relationships">
+  <p:cSld>
+    <p:spTree>
+      <p:nvGrpSpPr>
+        <p:cNvPr id="1" name=""/>
+        <p:cNvGrpSpPr/>
+        <p:nvPr/>
+      </p:nvGrpSpPr>
+      <p:grpSpPr/>
+      <p:pic>
+        <p:nvPicPr>
+          <p:cNvPr id="2" name="Picture 1" descr="slide_7_temp.png"/>
+          <p:cNvPicPr>
+            <a:picLocks noChangeAspect="1"/>
+          </p:cNvPicPr>
+          <p:nvPr/>
+        </p:nvPicPr>
+        <p:blipFill>
+          <a:blip r:embed="rId2"/>
+          <a:stretch>
+            <a:fillRect/>
+          </a:stretch>
+        </p:blipFill>
+        <p:spPr>
+          <a:xfrm>
+            <a:off x="0" y="0"/>
+            <a:ext cx="12191695" cy="6858000"/>
+          </a:xfrm>
+          <a:prstGeom prst="rect">
+            <a:avLst/>
+          </a:prstGeom>
+        </p:spPr>
+      </p:pic>
+    </p:spTree>
+  </p:cSld>
+  <p:clrMapOvr>
+    <a:masterClrMapping/>
+  </p:clrMapOvr>
+</p:sld>
+</file>
+
 <file path=ppt/theme/theme1.xml><?xml version="1.0" encoding="utf-8"?>
 <a:theme xmlns:a="http://schemas.openxmlformats.org/drawingml/2006/main" name="Office Theme">
   <a:themeElements>

</xml_diff>

<commit_message>
feat(slides): restyle Slide 4 to match reference layout with connected challenges-mitigations and technical notes
</commit_message>
<xml_diff>
--- a/SatQuery_AI_SIH2026_Idea_Submission_v2.pptx
+++ b/SatQuery_AI_SIH2026_Idea_Submission_v2.pptx
@@ -3096,7 +3096,7 @@
       <p:grpSpPr/>
       <p:pic>
         <p:nvPicPr>
-          <p:cNvPr id="2" name="Picture 1" descr="slide_1_temp.png"/>
+          <p:cNvPr id="2" name="Picture 1" descr="temp_s_1.png"/>
           <p:cNvPicPr>
             <a:picLocks noChangeAspect="1"/>
           </p:cNvPicPr>
@@ -3138,7 +3138,7 @@
       <p:grpSpPr/>
       <p:pic>
         <p:nvPicPr>
-          <p:cNvPr id="2" name="Picture 1" descr="slide_2_temp.png"/>
+          <p:cNvPr id="2" name="Picture 1" descr="temp_s_2.png"/>
           <p:cNvPicPr>
             <a:picLocks noChangeAspect="1"/>
           </p:cNvPicPr>
@@ -3180,7 +3180,7 @@
       <p:grpSpPr/>
       <p:pic>
         <p:nvPicPr>
-          <p:cNvPr id="2" name="Picture 1" descr="slide_3_temp.png"/>
+          <p:cNvPr id="2" name="Picture 1" descr="temp_s_3.png"/>
           <p:cNvPicPr>
             <a:picLocks noChangeAspect="1"/>
           </p:cNvPicPr>
@@ -3222,7 +3222,7 @@
       <p:grpSpPr/>
       <p:pic>
         <p:nvPicPr>
-          <p:cNvPr id="2" name="Picture 1" descr="slide_4_temp.png"/>
+          <p:cNvPr id="2" name="Picture 1" descr="temp_s_4.png"/>
           <p:cNvPicPr>
             <a:picLocks noChangeAspect="1"/>
           </p:cNvPicPr>
@@ -3264,7 +3264,7 @@
       <p:grpSpPr/>
       <p:pic>
         <p:nvPicPr>
-          <p:cNvPr id="2" name="Picture 1" descr="slide_5_temp.png"/>
+          <p:cNvPr id="2" name="Picture 1" descr="temp_s_5.png"/>
           <p:cNvPicPr>
             <a:picLocks noChangeAspect="1"/>
           </p:cNvPicPr>
@@ -3306,7 +3306,7 @@
       <p:grpSpPr/>
       <p:pic>
         <p:nvPicPr>
-          <p:cNvPr id="2" name="Picture 1" descr="slide_6_temp.png"/>
+          <p:cNvPr id="2" name="Picture 1" descr="temp_s_6.png"/>
           <p:cNvPicPr>
             <a:picLocks noChangeAspect="1"/>
           </p:cNvPicPr>
@@ -3348,7 +3348,7 @@
       <p:grpSpPr/>
       <p:pic>
         <p:nvPicPr>
-          <p:cNvPr id="2" name="Picture 1" descr="slide_7_temp.png"/>
+          <p:cNvPr id="2" name="Picture 1" descr="temp_s_7.png"/>
           <p:cNvPicPr>
             <a:picLocks noChangeAspect="1"/>
           </p:cNvPicPr>

</xml_diff>